<commit_message>
Unify design system: all architecture slides share one module
Created slide_design_system.py with ALL shared helpers and colors:
- Exact same add_rounded_rect, add_text_box, add_circle_number,
  add_section_header, add_process_card, add_flow_arrow, add_down_arrow
- Same function signatures, same defaults, same font sizes
- Same color palette (DARK_BG, SECTION_LABEL_BG, CARD_BG, etc.)
- Same card styling (Pt(2.5) border, 0.05 radius, 0.32" circle)
- Same foundation bar style (add_foundation_bar)
- Same slide header style (add_slide_header)

Both create_servicenow_ppt.py and create_eda_ppt.py now import from
slide_design_system.py — guaranteeing visual uniformity.

Stickiness colors (STICKY_HIGH/MED/LOW) added as extensions to the
shared palette, used only by EDA slides for border color coding.

https://claude.ai/code/session_01YC1hKPYHtsaUnfkxaHvcAA
</commit_message>
<xml_diff>
--- a/ServiceNow_Architecture.pptx
+++ b/ServiceNow_Architecture.pptx
@@ -6686,7 +6686,7 @@
         <p:spPr>
           <a:xfrm>
             <a:off x="457200" y="384048"/>
-            <a:ext cx="9144000" cy="365760"/>
+            <a:ext cx="7315200" cy="365760"/>
           </a:xfrm>
           <a:prstGeom prst="rect">
             <a:avLst/>
@@ -6715,7 +6715,40 @@
       </p:sp>
       <p:sp>
         <p:nvSpPr>
-          <p:cNvPr id="5" name="Rounded Rectangle 4"/>
+          <p:cNvPr id="5" name="TextBox 4"/>
+          <p:cNvSpPr txBox="1"/>
+          <p:nvPr/>
+        </p:nvSpPr>
+        <p:spPr>
+          <a:xfrm>
+            <a:off x="457200" y="713232"/>
+            <a:ext cx="9144000" cy="274320"/>
+          </a:xfrm>
+          <a:prstGeom prst="rect">
+            <a:avLst/>
+          </a:prstGeom>
+          <a:noFill/>
+        </p:spPr>
+        <p:txBody>
+          <a:bodyPr wrap="square">
+            <a:spAutoFit/>
+          </a:bodyPr>
+          <a:lstStyle/>
+          <a:p>
+            <a:pPr algn="l">
+              <a:defRPr sz="900" b="0">
+                <a:solidFill>
+                  <a:srgbClr val="8A93A6"/>
+                </a:solidFill>
+                <a:latin typeface="Segoe UI"/>
+              </a:defRPr>
+            </a:pPr>
+          </a:p>
+        </p:txBody>
+      </p:sp>
+      <p:sp>
+        <p:nvSpPr>
+          <p:cNvPr id="6" name="Rounded Rectangle 5"/>
           <p:cNvSpPr/>
           <p:nvPr/>
         </p:nvSpPr>
@@ -6760,7 +6793,7 @@
       </p:sp>
       <p:sp>
         <p:nvSpPr>
-          <p:cNvPr id="6" name="TextBox 5"/>
+          <p:cNvPr id="7" name="TextBox 6"/>
           <p:cNvSpPr txBox="1"/>
           <p:nvPr/>
         </p:nvSpPr>
@@ -6796,7 +6829,7 @@
       </p:sp>
       <p:sp>
         <p:nvSpPr>
-          <p:cNvPr id="7" name="Rounded Rectangle 6"/>
+          <p:cNvPr id="8" name="Rounded Rectangle 7"/>
           <p:cNvSpPr/>
           <p:nvPr/>
         </p:nvSpPr>
@@ -6843,7 +6876,7 @@
       </p:sp>
       <p:sp>
         <p:nvSpPr>
-          <p:cNvPr id="8" name="TextBox 7"/>
+          <p:cNvPr id="9" name="TextBox 8"/>
           <p:cNvSpPr txBox="1"/>
           <p:nvPr/>
         </p:nvSpPr>
@@ -6879,7 +6912,7 @@
       </p:sp>
       <p:sp>
         <p:nvSpPr>
-          <p:cNvPr id="9" name="TextBox 8"/>
+          <p:cNvPr id="10" name="TextBox 9"/>
           <p:cNvSpPr txBox="1"/>
           <p:nvPr/>
         </p:nvSpPr>
@@ -6915,7 +6948,7 @@
       </p:sp>
       <p:sp>
         <p:nvSpPr>
-          <p:cNvPr id="10" name="Rounded Rectangle 9"/>
+          <p:cNvPr id="11" name="Rounded Rectangle 10"/>
           <p:cNvSpPr/>
           <p:nvPr/>
         </p:nvSpPr>
@@ -6962,7 +6995,7 @@
       </p:sp>
       <p:sp>
         <p:nvSpPr>
-          <p:cNvPr id="11" name="TextBox 10"/>
+          <p:cNvPr id="12" name="TextBox 11"/>
           <p:cNvSpPr txBox="1"/>
           <p:nvPr/>
         </p:nvSpPr>
@@ -6998,7 +7031,7 @@
       </p:sp>
       <p:sp>
         <p:nvSpPr>
-          <p:cNvPr id="12" name="TextBox 11"/>
+          <p:cNvPr id="13" name="TextBox 12"/>
           <p:cNvSpPr txBox="1"/>
           <p:nvPr/>
         </p:nvSpPr>
@@ -7034,7 +7067,7 @@
       </p:sp>
       <p:sp>
         <p:nvSpPr>
-          <p:cNvPr id="13" name="Rounded Rectangle 12"/>
+          <p:cNvPr id="14" name="Rounded Rectangle 13"/>
           <p:cNvSpPr/>
           <p:nvPr/>
         </p:nvSpPr>
@@ -7081,7 +7114,7 @@
       </p:sp>
       <p:sp>
         <p:nvSpPr>
-          <p:cNvPr id="14" name="TextBox 13"/>
+          <p:cNvPr id="15" name="TextBox 14"/>
           <p:cNvSpPr txBox="1"/>
           <p:nvPr/>
         </p:nvSpPr>
@@ -7117,7 +7150,7 @@
       </p:sp>
       <p:sp>
         <p:nvSpPr>
-          <p:cNvPr id="15" name="TextBox 14"/>
+          <p:cNvPr id="16" name="TextBox 15"/>
           <p:cNvSpPr txBox="1"/>
           <p:nvPr/>
         </p:nvSpPr>
@@ -7153,7 +7186,7 @@
       </p:sp>
       <p:sp>
         <p:nvSpPr>
-          <p:cNvPr id="16" name="Rounded Rectangle 15"/>
+          <p:cNvPr id="17" name="Rounded Rectangle 16"/>
           <p:cNvSpPr/>
           <p:nvPr/>
         </p:nvSpPr>
@@ -7200,7 +7233,7 @@
       </p:sp>
       <p:sp>
         <p:nvSpPr>
-          <p:cNvPr id="17" name="TextBox 16"/>
+          <p:cNvPr id="18" name="TextBox 17"/>
           <p:cNvSpPr txBox="1"/>
           <p:nvPr/>
         </p:nvSpPr>
@@ -7236,7 +7269,7 @@
       </p:sp>
       <p:sp>
         <p:nvSpPr>
-          <p:cNvPr id="18" name="TextBox 17"/>
+          <p:cNvPr id="19" name="TextBox 18"/>
           <p:cNvSpPr txBox="1"/>
           <p:nvPr/>
         </p:nvSpPr>
@@ -7272,7 +7305,7 @@
       </p:sp>
       <p:sp>
         <p:nvSpPr>
-          <p:cNvPr id="19" name="Right Arrow 18"/>
+          <p:cNvPr id="20" name="Right Arrow 19"/>
           <p:cNvSpPr/>
           <p:nvPr/>
         </p:nvSpPr>
@@ -7315,7 +7348,7 @@
       </p:sp>
       <p:sp>
         <p:nvSpPr>
-          <p:cNvPr id="20" name="Rounded Rectangle 19"/>
+          <p:cNvPr id="21" name="Rounded Rectangle 20"/>
           <p:cNvSpPr/>
           <p:nvPr/>
         </p:nvSpPr>
@@ -7360,7 +7393,7 @@
       </p:sp>
       <p:sp>
         <p:nvSpPr>
-          <p:cNvPr id="21" name="TextBox 20"/>
+          <p:cNvPr id="22" name="TextBox 21"/>
           <p:cNvSpPr txBox="1"/>
           <p:nvPr/>
         </p:nvSpPr>
@@ -7396,7 +7429,7 @@
       </p:sp>
       <p:sp>
         <p:nvSpPr>
-          <p:cNvPr id="22" name="Rounded Rectangle 21"/>
+          <p:cNvPr id="23" name="Rounded Rectangle 22"/>
           <p:cNvSpPr/>
           <p:nvPr/>
         </p:nvSpPr>
@@ -7443,7 +7476,7 @@
       </p:sp>
       <p:sp>
         <p:nvSpPr>
-          <p:cNvPr id="23" name="TextBox 22"/>
+          <p:cNvPr id="24" name="TextBox 23"/>
           <p:cNvSpPr txBox="1"/>
           <p:nvPr/>
         </p:nvSpPr>
@@ -7479,7 +7512,7 @@
       </p:sp>
       <p:sp>
         <p:nvSpPr>
-          <p:cNvPr id="24" name="TextBox 23"/>
+          <p:cNvPr id="25" name="TextBox 24"/>
           <p:cNvSpPr txBox="1"/>
           <p:nvPr/>
         </p:nvSpPr>
@@ -7515,7 +7548,7 @@
       </p:sp>
       <p:sp>
         <p:nvSpPr>
-          <p:cNvPr id="25" name="Rounded Rectangle 24"/>
+          <p:cNvPr id="26" name="Rounded Rectangle 25"/>
           <p:cNvSpPr/>
           <p:nvPr/>
         </p:nvSpPr>
@@ -7562,7 +7595,7 @@
       </p:sp>
       <p:sp>
         <p:nvSpPr>
-          <p:cNvPr id="26" name="TextBox 25"/>
+          <p:cNvPr id="27" name="TextBox 26"/>
           <p:cNvSpPr txBox="1"/>
           <p:nvPr/>
         </p:nvSpPr>
@@ -7598,7 +7631,7 @@
       </p:sp>
       <p:sp>
         <p:nvSpPr>
-          <p:cNvPr id="27" name="TextBox 26"/>
+          <p:cNvPr id="28" name="TextBox 27"/>
           <p:cNvSpPr txBox="1"/>
           <p:nvPr/>
         </p:nvSpPr>
@@ -7634,7 +7667,7 @@
       </p:sp>
       <p:sp>
         <p:nvSpPr>
-          <p:cNvPr id="28" name="Rounded Rectangle 27"/>
+          <p:cNvPr id="29" name="Rounded Rectangle 28"/>
           <p:cNvSpPr/>
           <p:nvPr/>
         </p:nvSpPr>
@@ -7681,7 +7714,7 @@
       </p:sp>
       <p:sp>
         <p:nvSpPr>
-          <p:cNvPr id="29" name="TextBox 28"/>
+          <p:cNvPr id="30" name="TextBox 29"/>
           <p:cNvSpPr txBox="1"/>
           <p:nvPr/>
         </p:nvSpPr>
@@ -7717,7 +7750,7 @@
       </p:sp>
       <p:sp>
         <p:nvSpPr>
-          <p:cNvPr id="30" name="TextBox 29"/>
+          <p:cNvPr id="31" name="TextBox 30"/>
           <p:cNvSpPr txBox="1"/>
           <p:nvPr/>
         </p:nvSpPr>
@@ -7753,7 +7786,7 @@
       </p:sp>
       <p:sp>
         <p:nvSpPr>
-          <p:cNvPr id="31" name="Rounded Rectangle 30"/>
+          <p:cNvPr id="32" name="Rounded Rectangle 31"/>
           <p:cNvSpPr/>
           <p:nvPr/>
         </p:nvSpPr>
@@ -7800,7 +7833,7 @@
       </p:sp>
       <p:sp>
         <p:nvSpPr>
-          <p:cNvPr id="32" name="TextBox 31"/>
+          <p:cNvPr id="33" name="TextBox 32"/>
           <p:cNvSpPr txBox="1"/>
           <p:nvPr/>
         </p:nvSpPr>
@@ -7836,7 +7869,7 @@
       </p:sp>
       <p:sp>
         <p:nvSpPr>
-          <p:cNvPr id="33" name="TextBox 32"/>
+          <p:cNvPr id="34" name="TextBox 33"/>
           <p:cNvSpPr txBox="1"/>
           <p:nvPr/>
         </p:nvSpPr>
@@ -7872,7 +7905,7 @@
       </p:sp>
       <p:sp>
         <p:nvSpPr>
-          <p:cNvPr id="34" name="Right Arrow 33"/>
+          <p:cNvPr id="35" name="Right Arrow 34"/>
           <p:cNvSpPr/>
           <p:nvPr/>
         </p:nvSpPr>
@@ -7915,7 +7948,7 @@
       </p:sp>
       <p:sp>
         <p:nvSpPr>
-          <p:cNvPr id="35" name="Rounded Rectangle 34"/>
+          <p:cNvPr id="36" name="Rounded Rectangle 35"/>
           <p:cNvSpPr/>
           <p:nvPr/>
         </p:nvSpPr>
@@ -7960,7 +7993,7 @@
       </p:sp>
       <p:sp>
         <p:nvSpPr>
-          <p:cNvPr id="36" name="TextBox 35"/>
+          <p:cNvPr id="37" name="TextBox 36"/>
           <p:cNvSpPr txBox="1"/>
           <p:nvPr/>
         </p:nvSpPr>
@@ -7996,7 +8029,7 @@
       </p:sp>
       <p:sp>
         <p:nvSpPr>
-          <p:cNvPr id="37" name="Rounded Rectangle 36"/>
+          <p:cNvPr id="38" name="Rounded Rectangle 37"/>
           <p:cNvSpPr/>
           <p:nvPr/>
         </p:nvSpPr>
@@ -8043,7 +8076,7 @@
       </p:sp>
       <p:sp>
         <p:nvSpPr>
-          <p:cNvPr id="38" name="TextBox 37"/>
+          <p:cNvPr id="39" name="TextBox 38"/>
           <p:cNvSpPr txBox="1"/>
           <p:nvPr/>
         </p:nvSpPr>
@@ -8079,7 +8112,7 @@
       </p:sp>
       <p:sp>
         <p:nvSpPr>
-          <p:cNvPr id="39" name="TextBox 38"/>
+          <p:cNvPr id="40" name="TextBox 39"/>
           <p:cNvSpPr txBox="1"/>
           <p:nvPr/>
         </p:nvSpPr>
@@ -8115,7 +8148,7 @@
       </p:sp>
       <p:sp>
         <p:nvSpPr>
-          <p:cNvPr id="40" name="Rounded Rectangle 39"/>
+          <p:cNvPr id="41" name="Rounded Rectangle 40"/>
           <p:cNvSpPr/>
           <p:nvPr/>
         </p:nvSpPr>
@@ -8162,7 +8195,7 @@
       </p:sp>
       <p:sp>
         <p:nvSpPr>
-          <p:cNvPr id="41" name="TextBox 40"/>
+          <p:cNvPr id="42" name="TextBox 41"/>
           <p:cNvSpPr txBox="1"/>
           <p:nvPr/>
         </p:nvSpPr>
@@ -8198,7 +8231,7 @@
       </p:sp>
       <p:sp>
         <p:nvSpPr>
-          <p:cNvPr id="42" name="TextBox 41"/>
+          <p:cNvPr id="43" name="TextBox 42"/>
           <p:cNvSpPr txBox="1"/>
           <p:nvPr/>
         </p:nvSpPr>
@@ -8234,7 +8267,7 @@
       </p:sp>
       <p:sp>
         <p:nvSpPr>
-          <p:cNvPr id="43" name="Rounded Rectangle 42"/>
+          <p:cNvPr id="44" name="Rounded Rectangle 43"/>
           <p:cNvSpPr/>
           <p:nvPr/>
         </p:nvSpPr>
@@ -8281,7 +8314,7 @@
       </p:sp>
       <p:sp>
         <p:nvSpPr>
-          <p:cNvPr id="44" name="TextBox 43"/>
+          <p:cNvPr id="45" name="TextBox 44"/>
           <p:cNvSpPr txBox="1"/>
           <p:nvPr/>
         </p:nvSpPr>
@@ -8317,7 +8350,7 @@
       </p:sp>
       <p:sp>
         <p:nvSpPr>
-          <p:cNvPr id="45" name="TextBox 44"/>
+          <p:cNvPr id="46" name="TextBox 45"/>
           <p:cNvSpPr txBox="1"/>
           <p:nvPr/>
         </p:nvSpPr>
@@ -8353,7 +8386,7 @@
       </p:sp>
       <p:sp>
         <p:nvSpPr>
-          <p:cNvPr id="46" name="Rounded Rectangle 45"/>
+          <p:cNvPr id="47" name="Rounded Rectangle 46"/>
           <p:cNvSpPr/>
           <p:nvPr/>
         </p:nvSpPr>
@@ -8400,7 +8433,7 @@
       </p:sp>
       <p:sp>
         <p:nvSpPr>
-          <p:cNvPr id="47" name="TextBox 46"/>
+          <p:cNvPr id="48" name="TextBox 47"/>
           <p:cNvSpPr txBox="1"/>
           <p:nvPr/>
         </p:nvSpPr>
@@ -8436,7 +8469,7 @@
       </p:sp>
       <p:sp>
         <p:nvSpPr>
-          <p:cNvPr id="48" name="TextBox 47"/>
+          <p:cNvPr id="49" name="TextBox 48"/>
           <p:cNvSpPr txBox="1"/>
           <p:nvPr/>
         </p:nvSpPr>
@@ -8472,14 +8505,14 @@
       </p:sp>
       <p:sp>
         <p:nvSpPr>
-          <p:cNvPr id="49" name="Rounded Rectangle 48"/>
+          <p:cNvPr id="50" name="Rounded Rectangle 49"/>
           <p:cNvSpPr/>
           <p:nvPr/>
         </p:nvSpPr>
         <p:spPr>
           <a:xfrm>
             <a:off x="457200" y="5303520"/>
-            <a:ext cx="13716000" cy="502920"/>
+            <a:ext cx="13716000" cy="594360"/>
           </a:xfrm>
           <a:prstGeom prst="roundRect">
             <a:avLst>
@@ -8519,14 +8552,14 @@
       </p:sp>
       <p:sp>
         <p:nvSpPr>
-          <p:cNvPr id="50" name="TextBox 49"/>
+          <p:cNvPr id="51" name="TextBox 50"/>
           <p:cNvSpPr txBox="1"/>
           <p:nvPr/>
         </p:nvSpPr>
         <p:spPr>
           <a:xfrm>
-            <a:off x="640080" y="5376672"/>
-            <a:ext cx="12801600" cy="365760"/>
+            <a:off x="640080" y="5358384"/>
+            <a:ext cx="2743200" cy="274320"/>
           </a:xfrm>
           <a:prstGeom prst="rect">
             <a:avLst/>
@@ -8540,7 +8573,7 @@
           <a:lstStyle/>
           <a:p>
             <a:pPr algn="l">
-              <a:defRPr sz="1000" b="1">
+              <a:defRPr sz="1200" b="1">
                 <a:solidFill>
                   <a:srgbClr val="81B622"/>
                 </a:solidFill>
@@ -8548,7 +8581,43 @@
               </a:defRPr>
             </a:pPr>
             <a:r>
-              <a:t>NOW PLATFORM  •  Single Table Architecture  •  Update Sets &amp; Scoped Apps  •  Instance Security  •  MID Server  •  Domain Separation</a:t>
+              <a:t>NOW PLATFORM</a:t>
+            </a:r>
+          </a:p>
+        </p:txBody>
+      </p:sp>
+      <p:sp>
+        <p:nvSpPr>
+          <p:cNvPr id="52" name="TextBox 51"/>
+          <p:cNvSpPr txBox="1"/>
+          <p:nvPr/>
+        </p:nvSpPr>
+        <p:spPr>
+          <a:xfrm>
+            <a:off x="640080" y="5596128"/>
+            <a:ext cx="13350240" cy="274320"/>
+          </a:xfrm>
+          <a:prstGeom prst="rect">
+            <a:avLst/>
+          </a:prstGeom>
+          <a:noFill/>
+        </p:spPr>
+        <p:txBody>
+          <a:bodyPr wrap="square">
+            <a:spAutoFit/>
+          </a:bodyPr>
+          <a:lstStyle/>
+          <a:p>
+            <a:pPr algn="l">
+              <a:defRPr sz="900" b="0">
+                <a:solidFill>
+                  <a:srgbClr val="A5D6A7"/>
+                </a:solidFill>
+                <a:latin typeface="Segoe UI"/>
+              </a:defRPr>
+            </a:pPr>
+            <a:r>
+              <a:t>Single Table Architecture  •  Update Sets &amp; Scoped Apps  •  Instance Security  •  MID Server  •  Domain Separation</a:t>
             </a:r>
           </a:p>
         </p:txBody>
@@ -8667,7 +8736,7 @@
         <p:spPr>
           <a:xfrm>
             <a:off x="457200" y="384048"/>
-            <a:ext cx="9144000" cy="365760"/>
+            <a:ext cx="7315200" cy="365760"/>
           </a:xfrm>
           <a:prstGeom prst="rect">
             <a:avLst/>
@@ -8696,7 +8765,40 @@
       </p:sp>
       <p:sp>
         <p:nvSpPr>
-          <p:cNvPr id="5" name="Rounded Rectangle 4"/>
+          <p:cNvPr id="5" name="TextBox 4"/>
+          <p:cNvSpPr txBox="1"/>
+          <p:nvPr/>
+        </p:nvSpPr>
+        <p:spPr>
+          <a:xfrm>
+            <a:off x="457200" y="713232"/>
+            <a:ext cx="9144000" cy="274320"/>
+          </a:xfrm>
+          <a:prstGeom prst="rect">
+            <a:avLst/>
+          </a:prstGeom>
+          <a:noFill/>
+        </p:spPr>
+        <p:txBody>
+          <a:bodyPr wrap="square">
+            <a:spAutoFit/>
+          </a:bodyPr>
+          <a:lstStyle/>
+          <a:p>
+            <a:pPr algn="l">
+              <a:defRPr sz="900" b="0">
+                <a:solidFill>
+                  <a:srgbClr val="8A93A6"/>
+                </a:solidFill>
+                <a:latin typeface="Segoe UI"/>
+              </a:defRPr>
+            </a:pPr>
+          </a:p>
+        </p:txBody>
+      </p:sp>
+      <p:sp>
+        <p:nvSpPr>
+          <p:cNvPr id="6" name="Rounded Rectangle 5"/>
           <p:cNvSpPr/>
           <p:nvPr/>
         </p:nvSpPr>
@@ -8743,7 +8845,7 @@
       </p:sp>
       <p:sp>
         <p:nvSpPr>
-          <p:cNvPr id="6" name="TextBox 5"/>
+          <p:cNvPr id="7" name="TextBox 6"/>
           <p:cNvSpPr txBox="1"/>
           <p:nvPr/>
         </p:nvSpPr>
@@ -8779,7 +8881,7 @@
       </p:sp>
       <p:sp>
         <p:nvSpPr>
-          <p:cNvPr id="7" name="TextBox 6"/>
+          <p:cNvPr id="8" name="TextBox 7"/>
           <p:cNvSpPr txBox="1"/>
           <p:nvPr/>
         </p:nvSpPr>
@@ -8815,7 +8917,7 @@
       </p:sp>
       <p:sp>
         <p:nvSpPr>
-          <p:cNvPr id="8" name="TextBox 7"/>
+          <p:cNvPr id="9" name="TextBox 8"/>
           <p:cNvSpPr txBox="1"/>
           <p:nvPr/>
         </p:nvSpPr>
@@ -8855,7 +8957,7 @@
       </p:sp>
       <p:sp>
         <p:nvSpPr>
-          <p:cNvPr id="9" name="Rounded Rectangle 8"/>
+          <p:cNvPr id="10" name="Rounded Rectangle 9"/>
           <p:cNvSpPr/>
           <p:nvPr/>
         </p:nvSpPr>
@@ -8902,7 +9004,7 @@
       </p:sp>
       <p:sp>
         <p:nvSpPr>
-          <p:cNvPr id="10" name="TextBox 9"/>
+          <p:cNvPr id="11" name="TextBox 10"/>
           <p:cNvSpPr txBox="1"/>
           <p:nvPr/>
         </p:nvSpPr>
@@ -8938,7 +9040,7 @@
       </p:sp>
       <p:sp>
         <p:nvSpPr>
-          <p:cNvPr id="11" name="TextBox 10"/>
+          <p:cNvPr id="12" name="TextBox 11"/>
           <p:cNvSpPr txBox="1"/>
           <p:nvPr/>
         </p:nvSpPr>
@@ -8974,7 +9076,7 @@
       </p:sp>
       <p:sp>
         <p:nvSpPr>
-          <p:cNvPr id="12" name="TextBox 11"/>
+          <p:cNvPr id="13" name="TextBox 12"/>
           <p:cNvSpPr txBox="1"/>
           <p:nvPr/>
         </p:nvSpPr>
@@ -9014,7 +9116,7 @@
       </p:sp>
       <p:sp>
         <p:nvSpPr>
-          <p:cNvPr id="13" name="Rounded Rectangle 12"/>
+          <p:cNvPr id="14" name="Rounded Rectangle 13"/>
           <p:cNvSpPr/>
           <p:nvPr/>
         </p:nvSpPr>
@@ -9061,7 +9163,7 @@
       </p:sp>
       <p:sp>
         <p:nvSpPr>
-          <p:cNvPr id="14" name="TextBox 13"/>
+          <p:cNvPr id="15" name="TextBox 14"/>
           <p:cNvSpPr txBox="1"/>
           <p:nvPr/>
         </p:nvSpPr>
@@ -9097,7 +9199,7 @@
       </p:sp>
       <p:sp>
         <p:nvSpPr>
-          <p:cNvPr id="15" name="TextBox 14"/>
+          <p:cNvPr id="16" name="TextBox 15"/>
           <p:cNvSpPr txBox="1"/>
           <p:nvPr/>
         </p:nvSpPr>
@@ -9133,7 +9235,7 @@
       </p:sp>
       <p:sp>
         <p:nvSpPr>
-          <p:cNvPr id="16" name="TextBox 15"/>
+          <p:cNvPr id="17" name="TextBox 16"/>
           <p:cNvSpPr txBox="1"/>
           <p:nvPr/>
         </p:nvSpPr>
@@ -9173,7 +9275,7 @@
       </p:sp>
       <p:sp>
         <p:nvSpPr>
-          <p:cNvPr id="17" name="Rounded Rectangle 16"/>
+          <p:cNvPr id="18" name="Rounded Rectangle 17"/>
           <p:cNvSpPr/>
           <p:nvPr/>
         </p:nvSpPr>
@@ -9220,7 +9322,7 @@
       </p:sp>
       <p:sp>
         <p:nvSpPr>
-          <p:cNvPr id="18" name="TextBox 17"/>
+          <p:cNvPr id="19" name="TextBox 18"/>
           <p:cNvSpPr txBox="1"/>
           <p:nvPr/>
         </p:nvSpPr>
@@ -9256,7 +9358,7 @@
       </p:sp>
       <p:sp>
         <p:nvSpPr>
-          <p:cNvPr id="19" name="TextBox 18"/>
+          <p:cNvPr id="20" name="TextBox 19"/>
           <p:cNvSpPr txBox="1"/>
           <p:nvPr/>
         </p:nvSpPr>
@@ -9292,7 +9394,7 @@
       </p:sp>
       <p:sp>
         <p:nvSpPr>
-          <p:cNvPr id="20" name="TextBox 19"/>
+          <p:cNvPr id="21" name="TextBox 20"/>
           <p:cNvSpPr txBox="1"/>
           <p:nvPr/>
         </p:nvSpPr>
@@ -9332,7 +9434,7 @@
       </p:sp>
       <p:sp>
         <p:nvSpPr>
-          <p:cNvPr id="21" name="TextBox 20"/>
+          <p:cNvPr id="22" name="TextBox 21"/>
           <p:cNvSpPr txBox="1"/>
           <p:nvPr/>
         </p:nvSpPr>
@@ -9368,7 +9470,7 @@
       </p:sp>
       <p:graphicFrame>
         <p:nvGraphicFramePr>
-          <p:cNvPr id="22" name="Table 21"/>
+          <p:cNvPr id="23" name="Table 22"/>
           <p:cNvGraphicFramePr>
             <a:graphicFrameLocks noGrp="1"/>
           </p:cNvGraphicFramePr>

</xml_diff>